<commit_message>
docs: ajoute recursive splitting (slide 6), nettoie mentions obsoletes
</commit_message>
<xml_diff>
--- a/docs/presentation_rag.pptx
+++ b/docs/presentation_rag.pptx
@@ -2923,7 +2923,7 @@
                 <a:ea typeface="Calibri" pitchFamily="34" charset="-122"/>
                 <a:cs typeface="Calibri" pitchFamily="34" charset="-120"/>
               </a:rPr>
-              <a:t>CI rapide : requirements-ci.txt séparé</a:t>
+              <a:t>Adaptation de la CI aux sous-modules git (submodules: recursive)</a:t>
             </a:r>
             <a:endParaRPr lang="en-US" sz="1250" dirty="0"/>
           </a:p>
@@ -4901,8 +4901,8 @@
         </p:nvSpPr>
         <p:spPr>
           <a:xfrm>
-            <a:off x="548640" y="320040"/>
-            <a:ext cx="9144000" cy="548640"/>
+            <a:off x="548640" y="274320"/>
+            <a:ext cx="9144000" cy="457200"/>
           </a:xfrm>
           <a:prstGeom prst="rect">
             <a:avLst/>
@@ -4918,7 +4918,7 @@
               <a:buNone/>
             </a:pPr>
             <a:r>
-              <a:rPr lang="en-US" sz="3200" b="1" dirty="0">
+              <a:rPr lang="en-US" sz="2800" b="1" dirty="0">
                 <a:solidFill>
                   <a:srgbClr val="21295C"/>
                 </a:solidFill>
@@ -4928,7 +4928,7 @@
               </a:rPr>
               <a:t>Architecture système</a:t>
             </a:r>
-            <a:endParaRPr lang="en-US" sz="3200" dirty="0"/>
+            <a:endParaRPr lang="en-US" sz="2800" dirty="0"/>
           </a:p>
         </p:txBody>
       </p:sp>
@@ -4940,12 +4940,12 @@
         </p:nvSpPr>
         <p:spPr>
           <a:xfrm>
-            <a:off x="4892040" y="1051560"/>
-            <a:ext cx="2377440" cy="548640"/>
+            <a:off x="4892040" y="868680"/>
+            <a:ext cx="2377440" cy="457200"/>
           </a:xfrm>
           <a:prstGeom prst="roundRect">
             <a:avLst>
-              <a:gd name="adj" fmla="val 10000"/>
+              <a:gd name="adj" fmla="val 12000"/>
             </a:avLst>
           </a:prstGeom>
           <a:solidFill>
@@ -4962,8 +4962,8 @@
         </p:nvSpPr>
         <p:spPr>
           <a:xfrm>
-            <a:off x="4892040" y="1051560"/>
-            <a:ext cx="2377440" cy="548640"/>
+            <a:off x="4892040" y="868680"/>
+            <a:ext cx="2377440" cy="457200"/>
           </a:xfrm>
           <a:prstGeom prst="rect">
             <a:avLst/>
@@ -4979,7 +4979,7 @@
               <a:buNone/>
             </a:pPr>
             <a:r>
-              <a:rPr lang="en-US" sz="1200" b="1" dirty="0">
+              <a:rPr lang="en-US" sz="1100" b="1" dirty="0">
                 <a:solidFill>
                   <a:srgbClr val="FFFFFF"/>
                 </a:solidFill>
@@ -4989,7 +4989,7 @@
               </a:rPr>
               <a:t>Navigateur (utilisateur)</a:t>
             </a:r>
-            <a:endParaRPr lang="en-US" sz="1200" dirty="0"/>
+            <a:endParaRPr lang="en-US" sz="1100" dirty="0"/>
           </a:p>
         </p:txBody>
       </p:sp>
@@ -5001,8 +5001,8 @@
         </p:nvSpPr>
         <p:spPr>
           <a:xfrm>
-            <a:off x="5943600" y="1627632"/>
-            <a:ext cx="274320" cy="256032"/>
+            <a:off x="5943600" y="1344168"/>
+            <a:ext cx="274320" cy="201168"/>
           </a:xfrm>
           <a:prstGeom prst="downArrow">
             <a:avLst/>
@@ -5021,12 +5021,12 @@
         </p:nvSpPr>
         <p:spPr>
           <a:xfrm>
-            <a:off x="4709160" y="1920240"/>
-            <a:ext cx="2743200" cy="685800"/>
+            <a:off x="4709160" y="1572768"/>
+            <a:ext cx="2743200" cy="566928"/>
           </a:xfrm>
           <a:prstGeom prst="roundRect">
             <a:avLst>
-              <a:gd name="adj" fmla="val 8000"/>
+              <a:gd name="adj" fmla="val 9677"/>
             </a:avLst>
           </a:prstGeom>
           <a:solidFill>
@@ -5043,8 +5043,8 @@
         </p:nvSpPr>
         <p:spPr>
           <a:xfrm>
-            <a:off x="4709160" y="1920240"/>
-            <a:ext cx="2743200" cy="685800"/>
+            <a:off x="4709160" y="1572768"/>
+            <a:ext cx="2743200" cy="566928"/>
           </a:xfrm>
           <a:prstGeom prst="rect">
             <a:avLst/>
@@ -5060,7 +5060,7 @@
               <a:buNone/>
             </a:pPr>
             <a:r>
-              <a:rPr lang="en-US" sz="1200" b="1" dirty="0">
+              <a:rPr lang="en-US" sz="1100" b="1" dirty="0">
                 <a:solidFill>
                   <a:srgbClr val="FFFFFF"/>
                 </a:solidFill>
@@ -5068,26 +5068,9 @@
                 <a:ea typeface="Calibri" pitchFamily="34" charset="-122"/>
                 <a:cs typeface="Calibri" pitchFamily="34" charset="-120"/>
               </a:rPr>
-              <a:t>Streamlit UI</a:t>
-            </a:r>
-            <a:endParaRPr lang="en-US" sz="1200" dirty="0"/>
-          </a:p>
-          <a:p>
-            <a:pPr algn="ctr" indent="0" marL="0">
-              <a:buNone/>
-            </a:pPr>
-            <a:r>
-              <a:rPr lang="en-US" sz="1200" b="1" dirty="0">
-                <a:solidFill>
-                  <a:srgbClr val="FFFFFF"/>
-                </a:solidFill>
-                <a:latin typeface="Calibri" pitchFamily="34" charset="0"/>
-                <a:ea typeface="Calibri" pitchFamily="34" charset="-122"/>
-                <a:cs typeface="Calibri" pitchFamily="34" charset="-120"/>
-              </a:rPr>
-              <a:t>port 8501</a:t>
-            </a:r>
-            <a:endParaRPr lang="en-US" sz="1200" dirty="0"/>
+              <a:t>Streamlit UI — port 8501</a:t>
+            </a:r>
+            <a:endParaRPr lang="en-US" sz="1100" dirty="0"/>
           </a:p>
         </p:txBody>
       </p:sp>
@@ -5099,8 +5082,8 @@
         </p:nvSpPr>
         <p:spPr>
           <a:xfrm>
-            <a:off x="5943600" y="2651760"/>
-            <a:ext cx="274320" cy="256032"/>
+            <a:off x="5943600" y="2167128"/>
+            <a:ext cx="274320" cy="201168"/>
           </a:xfrm>
           <a:prstGeom prst="downArrow">
             <a:avLst/>
@@ -5119,12 +5102,12 @@
         </p:nvSpPr>
         <p:spPr>
           <a:xfrm>
-            <a:off x="4709160" y="2944368"/>
-            <a:ext cx="2743200" cy="685800"/>
+            <a:off x="4709160" y="2395728"/>
+            <a:ext cx="2743200" cy="566928"/>
           </a:xfrm>
           <a:prstGeom prst="roundRect">
             <a:avLst>
-              <a:gd name="adj" fmla="val 8000"/>
+              <a:gd name="adj" fmla="val 9677"/>
             </a:avLst>
           </a:prstGeom>
           <a:solidFill>
@@ -5141,8 +5124,8 @@
         </p:nvSpPr>
         <p:spPr>
           <a:xfrm>
-            <a:off x="4709160" y="2944368"/>
-            <a:ext cx="2743200" cy="685800"/>
+            <a:off x="4709160" y="2395728"/>
+            <a:ext cx="2743200" cy="566928"/>
           </a:xfrm>
           <a:prstGeom prst="rect">
             <a:avLst/>
@@ -5158,7 +5141,7 @@
               <a:buNone/>
             </a:pPr>
             <a:r>
-              <a:rPr lang="en-US" sz="1200" b="1" dirty="0">
+              <a:rPr lang="en-US" sz="1100" b="1" dirty="0">
                 <a:solidFill>
                   <a:srgbClr val="FFFFFF"/>
                 </a:solidFill>
@@ -5166,26 +5149,9 @@
                 <a:ea typeface="Calibri" pitchFamily="34" charset="-122"/>
                 <a:cs typeface="Calibri" pitchFamily="34" charset="-120"/>
               </a:rPr>
-              <a:t>FastAPI Backend</a:t>
-            </a:r>
-            <a:endParaRPr lang="en-US" sz="1200" dirty="0"/>
-          </a:p>
-          <a:p>
-            <a:pPr algn="ctr" indent="0" marL="0">
-              <a:buNone/>
-            </a:pPr>
-            <a:r>
-              <a:rPr lang="en-US" sz="1200" b="1" dirty="0">
-                <a:solidFill>
-                  <a:srgbClr val="FFFFFF"/>
-                </a:solidFill>
-                <a:latin typeface="Calibri" pitchFamily="34" charset="0"/>
-                <a:ea typeface="Calibri" pitchFamily="34" charset="-122"/>
-                <a:cs typeface="Calibri" pitchFamily="34" charset="-120"/>
-              </a:rPr>
-              <a:t>port 8000</a:t>
-            </a:r>
-            <a:endParaRPr lang="en-US" sz="1200" dirty="0"/>
+              <a:t>FastAPI Backend — port 8000</a:t>
+            </a:r>
+            <a:endParaRPr lang="en-US" sz="1100" dirty="0"/>
           </a:p>
         </p:txBody>
       </p:sp>
@@ -5197,13 +5163,11 @@
         </p:nvSpPr>
         <p:spPr>
           <a:xfrm>
-            <a:off x="822960" y="4343400"/>
-            <a:ext cx="2926080" cy="960120"/>
-          </a:xfrm>
-          <a:prstGeom prst="roundRect">
-            <a:avLst>
-              <a:gd name="adj" fmla="val 5714"/>
-            </a:avLst>
+            <a:off x="822960" y="3429000"/>
+            <a:ext cx="2743200" cy="914400"/>
+          </a:xfrm>
+          <a:prstGeom prst="can">
+            <a:avLst/>
           </a:prstGeom>
           <a:solidFill>
             <a:srgbClr val="21295C"/>
@@ -5219,24 +5183,24 @@
         </p:nvSpPr>
         <p:spPr>
           <a:xfrm>
-            <a:off x="822960" y="4343400"/>
-            <a:ext cx="2926080" cy="960120"/>
-          </a:xfrm>
-          <a:prstGeom prst="rect">
-            <a:avLst/>
-          </a:prstGeom>
-          <a:noFill/>
-          <a:ln/>
-        </p:spPr>
-        <p:txBody>
-          <a:bodyPr wrap="square" lIns="635" tIns="635" rIns="635" bIns="635" rtlCol="0" anchor="ctr"/>
+            <a:off x="822960" y="3520440"/>
+            <a:ext cx="2743200" cy="777240"/>
+          </a:xfrm>
+          <a:prstGeom prst="rect">
+            <a:avLst/>
+          </a:prstGeom>
+          <a:noFill/>
+          <a:ln/>
+        </p:spPr>
+        <p:txBody>
+          <a:bodyPr wrap="square" lIns="381" tIns="381" rIns="381" bIns="381" rtlCol="0" anchor="ctr"/>
           <a:lstStyle/>
           <a:p>
             <a:pPr algn="ctr" indent="0" marL="0">
               <a:buNone/>
             </a:pPr>
             <a:r>
-              <a:rPr lang="en-US" sz="1200" b="1" dirty="0">
+              <a:rPr lang="en-US" sz="1050" b="1" dirty="0">
                 <a:solidFill>
                   <a:srgbClr val="FFFFFF"/>
                 </a:solidFill>
@@ -5246,14 +5210,14 @@
               </a:rPr>
               <a:t>MinIO</a:t>
             </a:r>
-            <a:endParaRPr lang="en-US" sz="1200" dirty="0"/>
+            <a:endParaRPr lang="en-US" sz="1050" dirty="0"/>
           </a:p>
           <a:p>
             <a:pPr algn="ctr" indent="0" marL="0">
               <a:buNone/>
             </a:pPr>
             <a:r>
-              <a:rPr lang="en-US" sz="1200" b="1" dirty="0">
+              <a:rPr lang="en-US" sz="1050" b="1" dirty="0">
                 <a:solidFill>
                   <a:srgbClr val="FFFFFF"/>
                 </a:solidFill>
@@ -5263,14 +5227,14 @@
               </a:rPr>
               <a:t>Stockage objet</a:t>
             </a:r>
-            <a:endParaRPr lang="en-US" sz="1200" dirty="0"/>
+            <a:endParaRPr lang="en-US" sz="1050" dirty="0"/>
           </a:p>
           <a:p>
             <a:pPr algn="ctr" indent="0" marL="0">
               <a:buNone/>
             </a:pPr>
             <a:r>
-              <a:rPr lang="en-US" sz="1200" b="1" dirty="0">
+              <a:rPr lang="en-US" sz="1050" b="1" dirty="0">
                 <a:solidFill>
                   <a:srgbClr val="FFFFFF"/>
                 </a:solidFill>
@@ -5280,7 +5244,7 @@
               </a:rPr>
               <a:t>(document brut)</a:t>
             </a:r>
-            <a:endParaRPr lang="en-US" sz="1200" dirty="0"/>
+            <a:endParaRPr lang="en-US" sz="1050" dirty="0"/>
           </a:p>
         </p:txBody>
       </p:sp>
@@ -5292,13 +5256,11 @@
         </p:nvSpPr>
         <p:spPr>
           <a:xfrm>
-            <a:off x="4617720" y="4343400"/>
-            <a:ext cx="2926080" cy="960120"/>
-          </a:xfrm>
-          <a:prstGeom prst="roundRect">
-            <a:avLst>
-              <a:gd name="adj" fmla="val 5714"/>
-            </a:avLst>
+            <a:off x="4572000" y="3429000"/>
+            <a:ext cx="2834640" cy="914400"/>
+          </a:xfrm>
+          <a:prstGeom prst="can">
+            <a:avLst/>
           </a:prstGeom>
           <a:solidFill>
             <a:srgbClr val="21295C"/>
@@ -5314,24 +5276,24 @@
         </p:nvSpPr>
         <p:spPr>
           <a:xfrm>
-            <a:off x="4617720" y="4343400"/>
-            <a:ext cx="2926080" cy="960120"/>
-          </a:xfrm>
-          <a:prstGeom prst="rect">
-            <a:avLst/>
-          </a:prstGeom>
-          <a:noFill/>
-          <a:ln/>
-        </p:spPr>
-        <p:txBody>
-          <a:bodyPr wrap="square" lIns="635" tIns="635" rIns="635" bIns="635" rtlCol="0" anchor="ctr"/>
+            <a:off x="4572000" y="3520440"/>
+            <a:ext cx="2834640" cy="777240"/>
+          </a:xfrm>
+          <a:prstGeom prst="rect">
+            <a:avLst/>
+          </a:prstGeom>
+          <a:noFill/>
+          <a:ln/>
+        </p:spPr>
+        <p:txBody>
+          <a:bodyPr wrap="square" lIns="381" tIns="381" rIns="381" bIns="381" rtlCol="0" anchor="ctr"/>
           <a:lstStyle/>
           <a:p>
             <a:pPr algn="ctr" indent="0" marL="0">
               <a:buNone/>
             </a:pPr>
             <a:r>
-              <a:rPr lang="en-US" sz="1200" b="1" dirty="0">
+              <a:rPr lang="en-US" sz="1050" b="1" dirty="0">
                 <a:solidFill>
                   <a:srgbClr val="FFFFFF"/>
                 </a:solidFill>
@@ -5341,14 +5303,14 @@
               </a:rPr>
               <a:t>ChromaDB</a:t>
             </a:r>
-            <a:endParaRPr lang="en-US" sz="1200" dirty="0"/>
+            <a:endParaRPr lang="en-US" sz="1050" dirty="0"/>
           </a:p>
           <a:p>
             <a:pPr algn="ctr" indent="0" marL="0">
               <a:buNone/>
             </a:pPr>
             <a:r>
-              <a:rPr lang="en-US" sz="1200" b="1" dirty="0">
+              <a:rPr lang="en-US" sz="1050" b="1" dirty="0">
                 <a:solidFill>
                   <a:srgbClr val="FFFFFF"/>
                 </a:solidFill>
@@ -5358,14 +5320,14 @@
               </a:rPr>
               <a:t>Base vectorielle</a:t>
             </a:r>
-            <a:endParaRPr lang="en-US" sz="1200" dirty="0"/>
+            <a:endParaRPr lang="en-US" sz="1050" dirty="0"/>
           </a:p>
           <a:p>
             <a:pPr algn="ctr" indent="0" marL="0">
               <a:buNone/>
             </a:pPr>
             <a:r>
-              <a:rPr lang="en-US" sz="1200" b="1" dirty="0">
+              <a:rPr lang="en-US" sz="1050" b="1" dirty="0">
                 <a:solidFill>
                   <a:srgbClr val="FFFFFF"/>
                 </a:solidFill>
@@ -5375,7 +5337,7 @@
               </a:rPr>
               <a:t>(embeddings)</a:t>
             </a:r>
-            <a:endParaRPr lang="en-US" sz="1200" dirty="0"/>
+            <a:endParaRPr lang="en-US" sz="1050" dirty="0"/>
           </a:p>
         </p:txBody>
       </p:sp>
@@ -5387,12 +5349,12 @@
         </p:nvSpPr>
         <p:spPr>
           <a:xfrm>
-            <a:off x="8412480" y="4343400"/>
-            <a:ext cx="2926080" cy="960120"/>
+            <a:off x="8412480" y="3429000"/>
+            <a:ext cx="2834640" cy="914400"/>
           </a:xfrm>
           <a:prstGeom prst="roundRect">
             <a:avLst>
-              <a:gd name="adj" fmla="val 5714"/>
+              <a:gd name="adj" fmla="val 6000"/>
             </a:avLst>
           </a:prstGeom>
           <a:solidFill>
@@ -5409,8 +5371,8 @@
         </p:nvSpPr>
         <p:spPr>
           <a:xfrm>
-            <a:off x="8412480" y="4343400"/>
-            <a:ext cx="2926080" cy="960120"/>
+            <a:off x="8412480" y="3429000"/>
+            <a:ext cx="2834640" cy="914400"/>
           </a:xfrm>
           <a:prstGeom prst="rect">
             <a:avLst/>
@@ -5426,7 +5388,7 @@
               <a:buNone/>
             </a:pPr>
             <a:r>
-              <a:rPr lang="en-US" sz="1200" b="1" dirty="0">
+              <a:rPr lang="en-US" sz="1050" b="1" dirty="0">
                 <a:solidFill>
                   <a:srgbClr val="FFFFFF"/>
                 </a:solidFill>
@@ -5436,14 +5398,14 @@
               </a:rPr>
               <a:t>Ollama</a:t>
             </a:r>
-            <a:endParaRPr lang="en-US" sz="1200" dirty="0"/>
+            <a:endParaRPr lang="en-US" sz="1050" dirty="0"/>
           </a:p>
           <a:p>
             <a:pPr algn="ctr" indent="0" marL="0">
               <a:buNone/>
             </a:pPr>
             <a:r>
-              <a:rPr lang="en-US" sz="1200" b="1" dirty="0">
+              <a:rPr lang="en-US" sz="1050" b="1" dirty="0">
                 <a:solidFill>
                   <a:srgbClr val="FFFFFF"/>
                 </a:solidFill>
@@ -5453,14 +5415,14 @@
               </a:rPr>
               <a:t>qwen2.5:0.5b</a:t>
             </a:r>
-            <a:endParaRPr lang="en-US" sz="1200" dirty="0"/>
+            <a:endParaRPr lang="en-US" sz="1050" dirty="0"/>
           </a:p>
           <a:p>
             <a:pPr algn="ctr" indent="0" marL="0">
               <a:buNone/>
             </a:pPr>
             <a:r>
-              <a:rPr lang="en-US" sz="1200" b="1" dirty="0">
+              <a:rPr lang="en-US" sz="1050" b="1" dirty="0">
                 <a:solidFill>
                   <a:srgbClr val="FFFFFF"/>
                 </a:solidFill>
@@ -5470,7 +5432,7 @@
               </a:rPr>
               <a:t>(LLM local)</a:t>
             </a:r>
-            <a:endParaRPr lang="en-US" sz="1200" dirty="0"/>
+            <a:endParaRPr lang="en-US" sz="1050" dirty="0"/>
           </a:p>
         </p:txBody>
       </p:sp>
@@ -5482,8 +5444,8 @@
         </p:nvSpPr>
         <p:spPr>
           <a:xfrm>
-            <a:off x="6080760" y="3630168"/>
-            <a:ext cx="0" cy="393192"/>
+            <a:off x="6080760" y="2962656"/>
+            <a:ext cx="0" cy="283464"/>
           </a:xfrm>
           <a:prstGeom prst="line">
             <a:avLst/>
@@ -5505,8 +5467,8 @@
         </p:nvSpPr>
         <p:spPr>
           <a:xfrm>
-            <a:off x="2286000" y="4023360"/>
-            <a:ext cx="3794760" cy="0"/>
+            <a:off x="2194560" y="3246120"/>
+            <a:ext cx="3886200" cy="0"/>
           </a:xfrm>
           <a:prstGeom prst="line">
             <a:avLst/>
@@ -5528,8 +5490,8 @@
         </p:nvSpPr>
         <p:spPr>
           <a:xfrm>
-            <a:off x="6080760" y="4023360"/>
-            <a:ext cx="3794760" cy="0"/>
+            <a:off x="6080760" y="3246120"/>
+            <a:ext cx="3749040" cy="0"/>
           </a:xfrm>
           <a:prstGeom prst="line">
             <a:avLst/>
@@ -5551,8 +5513,8 @@
         </p:nvSpPr>
         <p:spPr>
           <a:xfrm>
-            <a:off x="2286000" y="4023360"/>
-            <a:ext cx="0" cy="320040"/>
+            <a:off x="2194560" y="3246120"/>
+            <a:ext cx="0" cy="182880"/>
           </a:xfrm>
           <a:prstGeom prst="line">
             <a:avLst/>
@@ -5574,8 +5536,8 @@
         </p:nvSpPr>
         <p:spPr>
           <a:xfrm>
-            <a:off x="6080760" y="4023360"/>
-            <a:ext cx="0" cy="320040"/>
+            <a:off x="6080760" y="3246120"/>
+            <a:ext cx="0" cy="182880"/>
           </a:xfrm>
           <a:prstGeom prst="line">
             <a:avLst/>
@@ -5597,8 +5559,8 @@
         </p:nvSpPr>
         <p:spPr>
           <a:xfrm>
-            <a:off x="9875520" y="4023360"/>
-            <a:ext cx="0" cy="320040"/>
+            <a:off x="9829800" y="3246120"/>
+            <a:ext cx="0" cy="182880"/>
           </a:xfrm>
           <a:prstGeom prst="line">
             <a:avLst/>
@@ -5620,8 +5582,8 @@
         </p:nvSpPr>
         <p:spPr>
           <a:xfrm>
-            <a:off x="548640" y="5532120"/>
-            <a:ext cx="10972800" cy="365760"/>
+            <a:off x="3108960" y="4526280"/>
+            <a:ext cx="5943600" cy="320040"/>
           </a:xfrm>
           <a:prstGeom prst="rect">
             <a:avLst/>
@@ -5637,7 +5599,384 @@
               <a:buNone/>
             </a:pPr>
             <a:r>
-              <a:rPr lang="en-US" sz="1100" i="1" dirty="0">
+              <a:rPr lang="en-US" sz="1400" b="1" dirty="0">
+                <a:solidFill>
+                  <a:srgbClr val="21295C"/>
+                </a:solidFill>
+                <a:latin typeface="Cambria" pitchFamily="34" charset="0"/>
+                <a:ea typeface="Cambria" pitchFamily="34" charset="-122"/>
+                <a:cs typeface="Cambria" pitchFamily="34" charset="-120"/>
+              </a:rPr>
+              <a:t>Versioning &amp; CI/CD</a:t>
+            </a:r>
+            <a:endParaRPr lang="en-US" sz="1400" dirty="0"/>
+          </a:p>
+        </p:txBody>
+      </p:sp>
+      <p:sp>
+        <p:nvSpPr>
+          <p:cNvPr id="24" name="Shape 22"/>
+          <p:cNvSpPr/>
+          <p:nvPr/>
+        </p:nvSpPr>
+        <p:spPr>
+          <a:xfrm>
+            <a:off x="2103120" y="4937760"/>
+            <a:ext cx="2286000" cy="868680"/>
+          </a:xfrm>
+          <a:prstGeom prst="can">
+            <a:avLst/>
+          </a:prstGeom>
+          <a:solidFill>
+            <a:srgbClr val="5B5B5B"/>
+          </a:solidFill>
+          <a:ln/>
+        </p:spPr>
+      </p:sp>
+      <p:sp>
+        <p:nvSpPr>
+          <p:cNvPr id="25" name="Text 23"/>
+          <p:cNvSpPr/>
+          <p:nvPr/>
+        </p:nvSpPr>
+        <p:spPr>
+          <a:xfrm>
+            <a:off x="2103120" y="5029200"/>
+            <a:ext cx="2286000" cy="731520"/>
+          </a:xfrm>
+          <a:prstGeom prst="rect">
+            <a:avLst/>
+          </a:prstGeom>
+          <a:noFill/>
+          <a:ln/>
+        </p:spPr>
+        <p:txBody>
+          <a:bodyPr wrap="square" lIns="381" tIns="381" rIns="381" bIns="381" rtlCol="0" anchor="ctr"/>
+          <a:lstStyle/>
+          <a:p>
+            <a:pPr algn="ctr" indent="0" marL="0">
+              <a:buNone/>
+            </a:pPr>
+            <a:r>
+              <a:rPr lang="en-US" sz="1000" b="1" dirty="0">
+                <a:solidFill>
+                  <a:srgbClr val="FFFFFF"/>
+                </a:solidFill>
+                <a:latin typeface="Calibri" pitchFamily="34" charset="0"/>
+                <a:ea typeface="Calibri" pitchFamily="34" charset="-122"/>
+                <a:cs typeface="Calibri" pitchFamily="34" charset="-120"/>
+              </a:rPr>
+              <a:t>Git</a:t>
+            </a:r>
+            <a:endParaRPr lang="en-US" sz="1000" dirty="0"/>
+          </a:p>
+          <a:p>
+            <a:pPr algn="ctr" indent="0" marL="0">
+              <a:buNone/>
+            </a:pPr>
+            <a:r>
+              <a:rPr lang="en-US" sz="1000" b="1" dirty="0">
+                <a:solidFill>
+                  <a:srgbClr val="FFFFFF"/>
+                </a:solidFill>
+                <a:latin typeface="Calibri" pitchFamily="34" charset="0"/>
+                <a:ea typeface="Calibri" pitchFamily="34" charset="-122"/>
+                <a:cs typeface="Calibri" pitchFamily="34" charset="-120"/>
+              </a:rPr>
+              <a:t>Dépôt eval_cloud</a:t>
+            </a:r>
+            <a:endParaRPr lang="en-US" sz="1000" dirty="0"/>
+          </a:p>
+          <a:p>
+            <a:pPr algn="ctr" indent="0" marL="0">
+              <a:buNone/>
+            </a:pPr>
+            <a:r>
+              <a:rPr lang="en-US" sz="1000" b="1" dirty="0">
+                <a:solidFill>
+                  <a:srgbClr val="FFFFFF"/>
+                </a:solidFill>
+                <a:latin typeface="Calibri" pitchFamily="34" charset="0"/>
+                <a:ea typeface="Calibri" pitchFamily="34" charset="-122"/>
+                <a:cs typeface="Calibri" pitchFamily="34" charset="-120"/>
+              </a:rPr>
+              <a:t>(GitHub)</a:t>
+            </a:r>
+            <a:endParaRPr lang="en-US" sz="1000" dirty="0"/>
+          </a:p>
+        </p:txBody>
+      </p:sp>
+      <p:sp>
+        <p:nvSpPr>
+          <p:cNvPr id="26" name="Shape 24"/>
+          <p:cNvSpPr/>
+          <p:nvPr/>
+        </p:nvSpPr>
+        <p:spPr>
+          <a:xfrm>
+            <a:off x="5120640" y="4956048"/>
+            <a:ext cx="2926080" cy="822960"/>
+          </a:xfrm>
+          <a:prstGeom prst="roundRect">
+            <a:avLst>
+              <a:gd name="adj" fmla="val 6667"/>
+            </a:avLst>
+          </a:prstGeom>
+          <a:solidFill>
+            <a:srgbClr val="B85042"/>
+          </a:solidFill>
+          <a:ln/>
+        </p:spPr>
+      </p:sp>
+      <p:sp>
+        <p:nvSpPr>
+          <p:cNvPr id="27" name="Text 25"/>
+          <p:cNvSpPr/>
+          <p:nvPr/>
+        </p:nvSpPr>
+        <p:spPr>
+          <a:xfrm>
+            <a:off x="5120640" y="4956048"/>
+            <a:ext cx="2926080" cy="822960"/>
+          </a:xfrm>
+          <a:prstGeom prst="rect">
+            <a:avLst/>
+          </a:prstGeom>
+          <a:noFill/>
+          <a:ln/>
+        </p:spPr>
+        <p:txBody>
+          <a:bodyPr wrap="square" lIns="635" tIns="635" rIns="635" bIns="635" rtlCol="0" anchor="ctr"/>
+          <a:lstStyle/>
+          <a:p>
+            <a:pPr algn="ctr" indent="0" marL="0">
+              <a:buNone/>
+            </a:pPr>
+            <a:r>
+              <a:rPr lang="en-US" sz="1050" b="1" dirty="0">
+                <a:solidFill>
+                  <a:srgbClr val="FFFFFF"/>
+                </a:solidFill>
+                <a:latin typeface="Calibri" pitchFamily="34" charset="0"/>
+                <a:ea typeface="Calibri" pitchFamily="34" charset="-122"/>
+                <a:cs typeface="Calibri" pitchFamily="34" charset="-120"/>
+              </a:rPr>
+              <a:t>CI/CD</a:t>
+            </a:r>
+            <a:endParaRPr lang="en-US" sz="1050" dirty="0"/>
+          </a:p>
+          <a:p>
+            <a:pPr algn="ctr" indent="0" marL="0">
+              <a:buNone/>
+            </a:pPr>
+            <a:r>
+              <a:rPr lang="en-US" sz="1050" b="1" dirty="0">
+                <a:solidFill>
+                  <a:srgbClr val="FFFFFF"/>
+                </a:solidFill>
+                <a:latin typeface="Calibri" pitchFamily="34" charset="0"/>
+                <a:ea typeface="Calibri" pitchFamily="34" charset="-122"/>
+                <a:cs typeface="Calibri" pitchFamily="34" charset="-120"/>
+              </a:rPr>
+              <a:t>GitHub Actions (ci.yml)</a:t>
+            </a:r>
+            <a:endParaRPr lang="en-US" sz="1050" dirty="0"/>
+          </a:p>
+        </p:txBody>
+      </p:sp>
+      <p:sp>
+        <p:nvSpPr>
+          <p:cNvPr id="28" name="Shape 26"/>
+          <p:cNvSpPr/>
+          <p:nvPr/>
+        </p:nvSpPr>
+        <p:spPr>
+          <a:xfrm>
+            <a:off x="4434840" y="5285232"/>
+            <a:ext cx="640080" cy="164592"/>
+          </a:xfrm>
+          <a:prstGeom prst="rightArrow">
+            <a:avLst/>
+          </a:prstGeom>
+          <a:solidFill>
+            <a:srgbClr val="191919"/>
+          </a:solidFill>
+          <a:ln/>
+        </p:spPr>
+      </p:sp>
+      <p:sp>
+        <p:nvSpPr>
+          <p:cNvPr id="29" name="Text 27"/>
+          <p:cNvSpPr/>
+          <p:nvPr/>
+        </p:nvSpPr>
+        <p:spPr>
+          <a:xfrm>
+            <a:off x="4343400" y="5468112"/>
+            <a:ext cx="868680" cy="274320"/>
+          </a:xfrm>
+          <a:prstGeom prst="rect">
+            <a:avLst/>
+          </a:prstGeom>
+          <a:noFill/>
+          <a:ln/>
+        </p:spPr>
+        <p:txBody>
+          <a:bodyPr wrap="square" lIns="0" tIns="0" rIns="0" bIns="0" rtlCol="0" anchor="ctr"/>
+          <a:lstStyle/>
+          <a:p>
+            <a:pPr algn="ctr" indent="0" marL="0">
+              <a:buNone/>
+            </a:pPr>
+            <a:r>
+              <a:rPr lang="en-US" sz="750" dirty="0">
+                <a:solidFill>
+                  <a:srgbClr val="191919"/>
+                </a:solidFill>
+                <a:latin typeface="Calibri" pitchFamily="34" charset="0"/>
+                <a:ea typeface="Calibri" pitchFamily="34" charset="-122"/>
+                <a:cs typeface="Calibri" pitchFamily="34" charset="-120"/>
+              </a:rPr>
+              <a:t>push / pull_request</a:t>
+            </a:r>
+            <a:endParaRPr lang="en-US" sz="750" dirty="0"/>
+          </a:p>
+        </p:txBody>
+      </p:sp>
+      <p:sp>
+        <p:nvSpPr>
+          <p:cNvPr id="30" name="Shape 28"/>
+          <p:cNvSpPr/>
+          <p:nvPr/>
+        </p:nvSpPr>
+        <p:spPr>
+          <a:xfrm>
+            <a:off x="8321040" y="5367528"/>
+            <a:ext cx="1234440" cy="0"/>
+          </a:xfrm>
+          <a:prstGeom prst="line">
+            <a:avLst/>
+          </a:prstGeom>
+          <a:noFill/>
+          <a:ln w="15875">
+            <a:solidFill>
+              <a:srgbClr val="B85042"/>
+            </a:solidFill>
+            <a:prstDash val="dash"/>
+          </a:ln>
+        </p:spPr>
+      </p:sp>
+      <p:sp>
+        <p:nvSpPr>
+          <p:cNvPr id="31" name="Shape 29"/>
+          <p:cNvSpPr/>
+          <p:nvPr/>
+        </p:nvSpPr>
+        <p:spPr>
+          <a:xfrm>
+            <a:off x="9555480" y="2679192"/>
+            <a:ext cx="0" cy="2688336"/>
+          </a:xfrm>
+          <a:prstGeom prst="line">
+            <a:avLst/>
+          </a:prstGeom>
+          <a:noFill/>
+          <a:ln w="15875">
+            <a:solidFill>
+              <a:srgbClr val="B85042"/>
+            </a:solidFill>
+            <a:prstDash val="dash"/>
+          </a:ln>
+        </p:spPr>
+      </p:sp>
+      <p:sp>
+        <p:nvSpPr>
+          <p:cNvPr id="32" name="Shape 30"/>
+          <p:cNvSpPr/>
+          <p:nvPr/>
+        </p:nvSpPr>
+        <p:spPr>
+          <a:xfrm>
+            <a:off x="7452360" y="2679192"/>
+            <a:ext cx="2103120" cy="0"/>
+          </a:xfrm>
+          <a:prstGeom prst="line">
+            <a:avLst/>
+          </a:prstGeom>
+          <a:noFill/>
+          <a:ln w="15875">
+            <a:solidFill>
+              <a:srgbClr val="B85042"/>
+            </a:solidFill>
+            <a:prstDash val="dash"/>
+          </a:ln>
+        </p:spPr>
+      </p:sp>
+      <p:sp>
+        <p:nvSpPr>
+          <p:cNvPr id="33" name="Text 31"/>
+          <p:cNvSpPr/>
+          <p:nvPr/>
+        </p:nvSpPr>
+        <p:spPr>
+          <a:xfrm>
+            <a:off x="8732520" y="3749040"/>
+            <a:ext cx="1463040" cy="274320"/>
+          </a:xfrm>
+          <a:prstGeom prst="rect">
+            <a:avLst/>
+          </a:prstGeom>
+          <a:noFill/>
+          <a:ln/>
+        </p:spPr>
+        <p:txBody>
+          <a:bodyPr wrap="square" lIns="0" tIns="0" rIns="0" bIns="0" rtlCol="0" anchor="ctr"/>
+          <a:lstStyle/>
+          <a:p>
+            <a:pPr algn="ctr" indent="0" marL="0">
+              <a:buNone/>
+            </a:pPr>
+            <a:r>
+              <a:rPr lang="en-US" sz="750" dirty="0">
+                <a:solidFill>
+                  <a:srgbClr val="B85042"/>
+                </a:solidFill>
+                <a:latin typeface="Calibri" pitchFamily="34" charset="0"/>
+                <a:ea typeface="Calibri" pitchFamily="34" charset="-122"/>
+                <a:cs typeface="Calibri" pitchFamily="34" charset="-120"/>
+              </a:rPr>
+              <a:t>teste et verifie</a:t>
+            </a:r>
+            <a:endParaRPr lang="en-US" sz="750" dirty="0"/>
+          </a:p>
+        </p:txBody>
+      </p:sp>
+      <p:sp>
+        <p:nvSpPr>
+          <p:cNvPr id="34" name="Text 32"/>
+          <p:cNvSpPr/>
+          <p:nvPr/>
+        </p:nvSpPr>
+        <p:spPr>
+          <a:xfrm>
+            <a:off x="914400" y="5943600"/>
+            <a:ext cx="10332720" cy="365760"/>
+          </a:xfrm>
+          <a:prstGeom prst="rect">
+            <a:avLst/>
+          </a:prstGeom>
+          <a:noFill/>
+          <a:ln/>
+        </p:spPr>
+        <p:txBody>
+          <a:bodyPr wrap="square" lIns="0" tIns="0" rIns="0" bIns="0" rtlCol="0" anchor="ctr"/>
+          <a:lstStyle/>
+          <a:p>
+            <a:pPr algn="ctr" indent="0" marL="0">
+              <a:buNone/>
+            </a:pPr>
+            <a:r>
+              <a:rPr lang="en-US" sz="950" i="1" dirty="0">
                 <a:solidFill>
                   <a:srgbClr val="5A6B7A"/>
                 </a:solidFill>
@@ -5645,9 +5984,48 @@
                 <a:ea typeface="Calibri" pitchFamily="34" charset="-122"/>
                 <a:cs typeface="Calibri" pitchFamily="34" charset="-120"/>
               </a:rPr>
+              <a:t>A chaque push/PR : checkout du code (avec sous-modules), installation des dependances, tests unitaires, verification de l'import du backend.</a:t>
+            </a:r>
+            <a:endParaRPr lang="en-US" sz="950" dirty="0"/>
+          </a:p>
+        </p:txBody>
+      </p:sp>
+      <p:sp>
+        <p:nvSpPr>
+          <p:cNvPr id="35" name="Text 33"/>
+          <p:cNvSpPr/>
+          <p:nvPr/>
+        </p:nvSpPr>
+        <p:spPr>
+          <a:xfrm>
+            <a:off x="548640" y="6355080"/>
+            <a:ext cx="10972800" cy="320040"/>
+          </a:xfrm>
+          <a:prstGeom prst="rect">
+            <a:avLst/>
+          </a:prstGeom>
+          <a:noFill/>
+          <a:ln/>
+        </p:spPr>
+        <p:txBody>
+          <a:bodyPr wrap="square" lIns="0" tIns="0" rIns="0" bIns="0" rtlCol="0" anchor="ctr"/>
+          <a:lstStyle/>
+          <a:p>
+            <a:pPr algn="ctr" indent="0" marL="0">
+              <a:buNone/>
+            </a:pPr>
+            <a:r>
+              <a:rPr lang="en-US" sz="950" i="1" dirty="0">
+                <a:solidFill>
+                  <a:srgbClr val="5A6B7A"/>
+                </a:solidFill>
+                <a:latin typeface="Calibri" pitchFamily="34" charset="0"/>
+                <a:ea typeface="Calibri" pitchFamily="34" charset="-122"/>
+                <a:cs typeface="Calibri" pitchFamily="34" charset="-120"/>
+              </a:rPr>
               <a:t>Environnement : GitHub Codespaces · MinIO via Docker Compose · Chroma persiste sur disque · Ollama tourne en local (CPU)</a:t>
             </a:r>
-            <a:endParaRPr lang="en-US" sz="1100" dirty="0"/>
+            <a:endParaRPr lang="en-US" sz="950" dirty="0"/>
           </a:p>
         </p:txBody>
       </p:sp>
@@ -7350,7 +7728,7 @@
         <p:spPr>
           <a:xfrm>
             <a:off x="548640" y="1188720"/>
-            <a:ext cx="3383280" cy="4206240"/>
+            <a:ext cx="3383280" cy="3657600"/>
           </a:xfrm>
           <a:prstGeom prst="roundRect">
             <a:avLst>
@@ -7383,8 +7761,8 @@
         </p:nvSpPr>
         <p:spPr>
           <a:xfrm>
-            <a:off x="548640" y="1463040"/>
-            <a:ext cx="3383280" cy="914400"/>
+            <a:off x="548640" y="1417320"/>
+            <a:ext cx="3383280" cy="822960"/>
           </a:xfrm>
           <a:prstGeom prst="rect">
             <a:avLst/>
@@ -7400,7 +7778,7 @@
               <a:buNone/>
             </a:pPr>
             <a:r>
-              <a:rPr lang="en-US" sz="6000" b="1" dirty="0">
+              <a:rPr lang="en-US" sz="5400" b="1" dirty="0">
                 <a:solidFill>
                   <a:srgbClr val="065A82"/>
                 </a:solidFill>
@@ -7410,7 +7788,7 @@
               </a:rPr>
               <a:t>800</a:t>
             </a:r>
-            <a:endParaRPr lang="en-US" sz="6000" dirty="0"/>
+            <a:endParaRPr lang="en-US" sz="5400" dirty="0"/>
           </a:p>
         </p:txBody>
       </p:sp>
@@ -7422,7 +7800,7 @@
         </p:nvSpPr>
         <p:spPr>
           <a:xfrm>
-            <a:off x="548640" y="2331720"/>
+            <a:off x="548640" y="2194560"/>
             <a:ext cx="3383280" cy="365760"/>
           </a:xfrm>
           <a:prstGeom prst="rect">
@@ -7461,8 +7839,8 @@
         </p:nvSpPr>
         <p:spPr>
           <a:xfrm>
-            <a:off x="868680" y="2926080"/>
-            <a:ext cx="2743200" cy="1371600"/>
+            <a:off x="868680" y="2697480"/>
+            <a:ext cx="2743200" cy="1097280"/>
           </a:xfrm>
           <a:prstGeom prst="rect">
             <a:avLst/>
@@ -7501,7 +7879,7 @@
         <p:spPr>
           <a:xfrm>
             <a:off x="4251960" y="1188720"/>
-            <a:ext cx="3383280" cy="4206240"/>
+            <a:ext cx="3383280" cy="3657600"/>
           </a:xfrm>
           <a:prstGeom prst="roundRect">
             <a:avLst>
@@ -7534,8 +7912,8 @@
         </p:nvSpPr>
         <p:spPr>
           <a:xfrm>
-            <a:off x="4251960" y="1463040"/>
-            <a:ext cx="3383280" cy="914400"/>
+            <a:off x="4251960" y="1417320"/>
+            <a:ext cx="3383280" cy="822960"/>
           </a:xfrm>
           <a:prstGeom prst="rect">
             <a:avLst/>
@@ -7551,7 +7929,7 @@
               <a:buNone/>
             </a:pPr>
             <a:r>
-              <a:rPr lang="en-US" sz="6000" b="1" dirty="0">
+              <a:rPr lang="en-US" sz="5400" b="1" dirty="0">
                 <a:solidFill>
                   <a:srgbClr val="1C7293"/>
                 </a:solidFill>
@@ -7561,7 +7939,7 @@
               </a:rPr>
               <a:t>120</a:t>
             </a:r>
-            <a:endParaRPr lang="en-US" sz="6000" dirty="0"/>
+            <a:endParaRPr lang="en-US" sz="5400" dirty="0"/>
           </a:p>
         </p:txBody>
       </p:sp>
@@ -7573,7 +7951,7 @@
         </p:nvSpPr>
         <p:spPr>
           <a:xfrm>
-            <a:off x="4251960" y="2331720"/>
+            <a:off x="4251960" y="2194560"/>
             <a:ext cx="3383280" cy="365760"/>
           </a:xfrm>
           <a:prstGeom prst="rect">
@@ -7612,8 +7990,8 @@
         </p:nvSpPr>
         <p:spPr>
           <a:xfrm>
-            <a:off x="4572000" y="2926080"/>
-            <a:ext cx="2743200" cy="1371600"/>
+            <a:off x="4572000" y="2697480"/>
+            <a:ext cx="2743200" cy="1097280"/>
           </a:xfrm>
           <a:prstGeom prst="rect">
             <a:avLst/>
@@ -7652,7 +8030,7 @@
         <p:spPr>
           <a:xfrm>
             <a:off x="7955280" y="1188720"/>
-            <a:ext cx="3383280" cy="4206240"/>
+            <a:ext cx="3383280" cy="3657600"/>
           </a:xfrm>
           <a:prstGeom prst="roundRect">
             <a:avLst>
@@ -7685,8 +8063,8 @@
         </p:nvSpPr>
         <p:spPr>
           <a:xfrm>
-            <a:off x="7955280" y="1463040"/>
-            <a:ext cx="3383280" cy="914400"/>
+            <a:off x="7955280" y="1417320"/>
+            <a:ext cx="3383280" cy="822960"/>
           </a:xfrm>
           <a:prstGeom prst="rect">
             <a:avLst/>
@@ -7702,7 +8080,7 @@
               <a:buNone/>
             </a:pPr>
             <a:r>
-              <a:rPr lang="en-US" sz="6000" b="1" dirty="0">
+              <a:rPr lang="en-US" sz="5400" b="1" dirty="0">
                 <a:solidFill>
                   <a:srgbClr val="B85042"/>
                 </a:solidFill>
@@ -7712,7 +8090,7 @@
               </a:rPr>
               <a:t>4</a:t>
             </a:r>
-            <a:endParaRPr lang="en-US" sz="6000" dirty="0"/>
+            <a:endParaRPr lang="en-US" sz="5400" dirty="0"/>
           </a:p>
         </p:txBody>
       </p:sp>
@@ -7724,7 +8102,7 @@
         </p:nvSpPr>
         <p:spPr>
           <a:xfrm>
-            <a:off x="7955280" y="2331720"/>
+            <a:off x="7955280" y="2194560"/>
             <a:ext cx="3383280" cy="365760"/>
           </a:xfrm>
           <a:prstGeom prst="rect">
@@ -7763,8 +8141,8 @@
         </p:nvSpPr>
         <p:spPr>
           <a:xfrm>
-            <a:off x="8275320" y="2926080"/>
-            <a:ext cx="2743200" cy="1371600"/>
+            <a:off x="8275320" y="2697480"/>
+            <a:ext cx="2743200" cy="1097280"/>
           </a:xfrm>
           <a:prstGeom prst="rect">
             <a:avLst/>
@@ -7796,13 +8174,164 @@
       </p:sp>
       <p:sp>
         <p:nvSpPr>
-          <p:cNvPr id="15" name="Text 13"/>
-          <p:cNvSpPr/>
-          <p:nvPr/>
-        </p:nvSpPr>
-        <p:spPr>
-          <a:xfrm>
-            <a:off x="548640" y="5623560"/>
+          <p:cNvPr id="15" name="Shape 13"/>
+          <p:cNvSpPr/>
+          <p:nvPr/>
+        </p:nvSpPr>
+        <p:spPr>
+          <a:xfrm>
+            <a:off x="548640" y="5029200"/>
+            <a:ext cx="10789920" cy="777240"/>
+          </a:xfrm>
+          <a:prstGeom prst="roundRect">
+            <a:avLst>
+              <a:gd name="adj" fmla="val 9412"/>
+            </a:avLst>
+          </a:prstGeom>
+          <a:solidFill>
+            <a:srgbClr val="F0F9FB"/>
+          </a:solidFill>
+          <a:ln w="12700">
+            <a:solidFill>
+              <a:srgbClr val="E2E8F0"/>
+            </a:solidFill>
+            <a:prstDash val="solid"/>
+          </a:ln>
+          <a:effectLst>
+            <a:outerShdw sx="100000" sy="100000" kx="0" ky="0" algn="bl" rotWithShape="0" blurRad="101600" dist="38100" dir="5400000">
+              <a:srgbClr val="000000">
+                <a:alpha val="12000"/>
+              </a:srgbClr>
+            </a:outerShdw>
+          </a:effectLst>
+        </p:spPr>
+      </p:sp>
+      <p:sp>
+        <p:nvSpPr>
+          <p:cNvPr id="16" name="Text 14"/>
+          <p:cNvSpPr/>
+          <p:nvPr/>
+        </p:nvSpPr>
+        <p:spPr>
+          <a:xfrm>
+            <a:off x="777240" y="5029200"/>
+            <a:ext cx="1920240" cy="777240"/>
+          </a:xfrm>
+          <a:prstGeom prst="rect">
+            <a:avLst/>
+          </a:prstGeom>
+          <a:noFill/>
+          <a:ln/>
+        </p:spPr>
+        <p:txBody>
+          <a:bodyPr wrap="square" lIns="0" tIns="0" rIns="0" bIns="0" rtlCol="0" anchor="ctr"/>
+          <a:lstStyle/>
+          <a:p>
+            <a:pPr indent="0" marL="0">
+              <a:buNone/>
+            </a:pPr>
+            <a:r>
+              <a:rPr lang="en-US" sz="1300" b="1" dirty="0">
+                <a:solidFill>
+                  <a:srgbClr val="065A82"/>
+                </a:solidFill>
+                <a:latin typeface="Calibri" pitchFamily="34" charset="0"/>
+                <a:ea typeface="Calibri" pitchFamily="34" charset="-122"/>
+                <a:cs typeface="Calibri" pitchFamily="34" charset="-120"/>
+              </a:rPr>
+              <a:t>Recursive splitting</a:t>
+            </a:r>
+            <a:endParaRPr lang="en-US" sz="1300" dirty="0"/>
+          </a:p>
+        </p:txBody>
+      </p:sp>
+      <p:sp>
+        <p:nvSpPr>
+          <p:cNvPr id="17" name="Text 15"/>
+          <p:cNvSpPr/>
+          <p:nvPr/>
+        </p:nvSpPr>
+        <p:spPr>
+          <a:xfrm>
+            <a:off x="2788920" y="5029200"/>
+            <a:ext cx="5486400" cy="777240"/>
+          </a:xfrm>
+          <a:prstGeom prst="rect">
+            <a:avLst/>
+          </a:prstGeom>
+          <a:noFill/>
+          <a:ln/>
+        </p:spPr>
+        <p:txBody>
+          <a:bodyPr wrap="square" lIns="0" tIns="0" rIns="0" bIns="0" rtlCol="0" anchor="ctr"/>
+          <a:lstStyle/>
+          <a:p>
+            <a:pPr indent="0" marL="0">
+              <a:buNone/>
+            </a:pPr>
+            <a:r>
+              <a:rPr lang="en-US" sz="1150" dirty="0">
+                <a:solidFill>
+                  <a:srgbClr val="334155"/>
+                </a:solidFill>
+                <a:latin typeface="Calibri" pitchFamily="34" charset="0"/>
+                <a:ea typeface="Calibri" pitchFamily="34" charset="-122"/>
+                <a:cs typeface="Calibri" pitchFamily="34" charset="-120"/>
+              </a:rPr>
+              <a:t>Couper en respectant paragraphes → phrases → mots (RecursiveCharacterTextSplitter)</a:t>
+            </a:r>
+            <a:endParaRPr lang="en-US" sz="1150" dirty="0"/>
+          </a:p>
+        </p:txBody>
+      </p:sp>
+      <p:sp>
+        <p:nvSpPr>
+          <p:cNvPr id="18" name="Text 16"/>
+          <p:cNvSpPr/>
+          <p:nvPr/>
+        </p:nvSpPr>
+        <p:spPr>
+          <a:xfrm>
+            <a:off x="8366760" y="5029200"/>
+            <a:ext cx="2834640" cy="777240"/>
+          </a:xfrm>
+          <a:prstGeom prst="rect">
+            <a:avLst/>
+          </a:prstGeom>
+          <a:noFill/>
+          <a:ln/>
+        </p:spPr>
+        <p:txBody>
+          <a:bodyPr wrap="square" lIns="0" tIns="0" rIns="0" bIns="0" rtlCol="0" anchor="ctr"/>
+          <a:lstStyle/>
+          <a:p>
+            <a:pPr indent="0" marL="0">
+              <a:buNone/>
+            </a:pPr>
+            <a:r>
+              <a:rPr lang="en-US" sz="1100" i="1" dirty="0">
+                <a:solidFill>
+                  <a:srgbClr val="2C5F2D"/>
+                </a:solidFill>
+                <a:latin typeface="Calibri" pitchFamily="34" charset="0"/>
+                <a:ea typeface="Calibri" pitchFamily="34" charset="-122"/>
+                <a:cs typeface="Calibri" pitchFamily="34" charset="-120"/>
+              </a:rPr>
+              <a:t>Évite de couper au milieu d'une phrase</a:t>
+            </a:r>
+            <a:endParaRPr lang="en-US" sz="1100" dirty="0"/>
+          </a:p>
+        </p:txBody>
+      </p:sp>
+      <p:sp>
+        <p:nvSpPr>
+          <p:cNvPr id="19" name="Text 17"/>
+          <p:cNvSpPr/>
+          <p:nvPr/>
+        </p:nvSpPr>
+        <p:spPr>
+          <a:xfrm>
+            <a:off x="548640" y="5943600"/>
             <a:ext cx="10972800" cy="365760"/>
           </a:xfrm>
           <a:prstGeom prst="rect">
@@ -7819,7 +8348,7 @@
               <a:buNone/>
             </a:pPr>
             <a:r>
-              <a:rPr lang="en-US" sz="1200" i="1" dirty="0">
+              <a:rPr lang="en-US" sz="1150" i="1" dirty="0">
                 <a:solidFill>
                   <a:srgbClr val="5A6B7A"/>
                 </a:solidFill>
@@ -7829,7 +8358,7 @@
               </a:rPr>
               <a:t>Modèle d'embeddings : sentence-transformers/paraphrase-multilingual-MiniLM-L12-v2 — léger (~470 Mo), multilingue, tourne sur CPU.</a:t>
             </a:r>
-            <a:endParaRPr lang="en-US" sz="1200" dirty="0"/>
+            <a:endParaRPr lang="en-US" sz="1150" dirty="0"/>
           </a:p>
         </p:txBody>
       </p:sp>
@@ -10009,6 +10538,23 @@
             </a:r>
             <a:endParaRPr lang="en-US" sz="1100" dirty="0"/>
           </a:p>
+          <a:p>
+            <a:pPr algn="ctr" indent="0" marL="0">
+              <a:buNone/>
+            </a:pPr>
+            <a:r>
+              <a:rPr lang="en-US" sz="1100" b="1" dirty="0">
+                <a:solidFill>
+                  <a:srgbClr val="FFFFFF"/>
+                </a:solidFill>
+                <a:latin typeface="Calibri" pitchFamily="34" charset="0"/>
+                <a:ea typeface="Calibri" pitchFamily="34" charset="-122"/>
+                <a:cs typeface="Calibri" pitchFamily="34" charset="-120"/>
+              </a:rPr>
+              <a:t>(avec sous-modules)</a:t>
+            </a:r>
+            <a:endParaRPr lang="en-US" sz="1100" dirty="0"/>
+          </a:p>
         </p:txBody>
       </p:sp>
       <p:sp>
@@ -10103,7 +10649,7 @@
                 <a:ea typeface="Calibri" pitchFamily="34" charset="-122"/>
                 <a:cs typeface="Calibri" pitchFamily="34" charset="-120"/>
               </a:rPr>
-              <a:t>(requirements-ci.txt)</a:t>
+              <a:t>(backend/requirements.txt)</a:t>
             </a:r>
             <a:endParaRPr lang="en-US" sz="1100" dirty="0"/>
           </a:p>
@@ -10184,7 +10730,7 @@
                 <a:ea typeface="Calibri" pitchFamily="34" charset="-122"/>
                 <a:cs typeface="Calibri" pitchFamily="34" charset="-120"/>
               </a:rPr>
-              <a:t>pytest tests/</a:t>
+              <a:t>pytest -v</a:t>
             </a:r>
             <a:endParaRPr lang="en-US" sz="1100" dirty="0"/>
           </a:p>
@@ -10282,7 +10828,7 @@
                 <a:ea typeface="Calibri" pitchFamily="34" charset="-122"/>
                 <a:cs typeface="Calibri" pitchFamily="34" charset="-120"/>
               </a:rPr>
-              <a:t>backend.main</a:t>
+              <a:t>du backend</a:t>
             </a:r>
             <a:endParaRPr lang="en-US" sz="1100" dirty="0"/>
           </a:p>
@@ -10355,7 +10901,7 @@
                 <a:ea typeface="Calibri" pitchFamily="34" charset="-122"/>
                 <a:cs typeface="Calibri" pitchFamily="34" charset="-120"/>
               </a:rPr>
-              <a:t>3 fichiers de tests indépendants</a:t>
+              <a:t>Tests du backend</a:t>
             </a:r>
             <a:endParaRPr lang="en-US" sz="1400" dirty="0"/>
           </a:p>
@@ -10369,63 +10915,27 @@
         </p:nvSpPr>
         <p:spPr>
           <a:xfrm>
-            <a:off x="822960" y="3520440"/>
-            <a:ext cx="1920240" cy="384048"/>
-          </a:xfrm>
-          <a:prstGeom prst="rect">
-            <a:avLst/>
-          </a:prstGeom>
-          <a:noFill/>
-          <a:ln/>
-        </p:spPr>
-        <p:txBody>
-          <a:bodyPr wrap="square" lIns="0" tIns="0" rIns="0" bIns="0" rtlCol="0" anchor="ctr"/>
+            <a:off x="822960" y="3474720"/>
+            <a:ext cx="4754880" cy="2286000"/>
+          </a:xfrm>
+          <a:prstGeom prst="rect">
+            <a:avLst/>
+          </a:prstGeom>
+          <a:noFill/>
+          <a:ln/>
+        </p:spPr>
+        <p:txBody>
+          <a:bodyPr wrap="square" lIns="0" tIns="0" rIns="0" bIns="0" rtlCol="0" anchor="t"/>
           <a:lstStyle/>
           <a:p>
             <a:pPr indent="0" marL="0">
-              <a:buNone/>
-            </a:pPr>
-            <a:r>
-              <a:rPr lang="en-US" sz="1200" b="1" dirty="0">
-                <a:solidFill>
-                  <a:srgbClr val="065A82"/>
-                </a:solidFill>
-                <a:latin typeface="Courier New" pitchFamily="34" charset="0"/>
-                <a:ea typeface="Courier New" pitchFamily="34" charset="-122"/>
-                <a:cs typeface="Courier New" pitchFamily="34" charset="-120"/>
-              </a:rPr>
-              <a:t>test_chunking.py</a:t>
-            </a:r>
-            <a:endParaRPr lang="en-US" sz="1200" dirty="0"/>
-          </a:p>
-        </p:txBody>
-      </p:sp>
-      <p:sp>
-        <p:nvSpPr>
-          <p:cNvPr id="21" name="Text 19"/>
-          <p:cNvSpPr/>
-          <p:nvPr/>
-        </p:nvSpPr>
-        <p:spPr>
-          <a:xfrm>
-            <a:off x="2788920" y="3520440"/>
-            <a:ext cx="2926080" cy="384048"/>
-          </a:xfrm>
-          <a:prstGeom prst="rect">
-            <a:avLst/>
-          </a:prstGeom>
-          <a:noFill/>
-          <a:ln/>
-        </p:spPr>
-        <p:txBody>
-          <a:bodyPr wrap="square" lIns="0" tIns="0" rIns="0" bIns="0" rtlCol="0" anchor="ctr"/>
-          <a:lstStyle/>
-          <a:p>
-            <a:pPr indent="0" marL="0">
-              <a:buNone/>
-            </a:pPr>
-            <a:r>
-              <a:rPr lang="en-US" sz="1150" dirty="0">
+              <a:lnSpc>
+                <a:spcPct val="125000"/>
+              </a:lnSpc>
+              <a:buNone/>
+            </a:pPr>
+            <a:r>
+              <a:rPr lang="en-US" sz="1250" dirty="0">
                 <a:solidFill>
                   <a:srgbClr val="334155"/>
                 </a:solidFill>
@@ -10433,171 +10943,15 @@
                 <a:ea typeface="Calibri" pitchFamily="34" charset="-122"/>
                 <a:cs typeface="Calibri" pitchFamily="34" charset="-120"/>
               </a:rPr>
-              <a:t>découpage correct d'un texte en passages</a:t>
-            </a:r>
-            <a:endParaRPr lang="en-US" sz="1150" dirty="0"/>
-          </a:p>
-        </p:txBody>
-      </p:sp>
-      <p:sp>
-        <p:nvSpPr>
-          <p:cNvPr id="22" name="Text 20"/>
-          <p:cNvSpPr/>
-          <p:nvPr/>
-        </p:nvSpPr>
-        <p:spPr>
-          <a:xfrm>
-            <a:off x="822960" y="4069080"/>
-            <a:ext cx="1920240" cy="384048"/>
-          </a:xfrm>
-          <a:prstGeom prst="rect">
-            <a:avLst/>
-          </a:prstGeom>
-          <a:noFill/>
-          <a:ln/>
-        </p:spPr>
-        <p:txBody>
-          <a:bodyPr wrap="square" lIns="0" tIns="0" rIns="0" bIns="0" rtlCol="0" anchor="ctr"/>
-          <a:lstStyle/>
-          <a:p>
-            <a:pPr indent="0" marL="0">
-              <a:buNone/>
-            </a:pPr>
-            <a:r>
-              <a:rPr lang="en-US" sz="1200" b="1" dirty="0">
-                <a:solidFill>
-                  <a:srgbClr val="065A82"/>
-                </a:solidFill>
-                <a:latin typeface="Courier New" pitchFamily="34" charset="0"/>
-                <a:ea typeface="Courier New" pitchFamily="34" charset="-122"/>
-                <a:cs typeface="Courier New" pitchFamily="34" charset="-120"/>
-              </a:rPr>
-              <a:t>test_prompt.py</a:t>
-            </a:r>
-            <a:endParaRPr lang="en-US" sz="1200" dirty="0"/>
-          </a:p>
-        </p:txBody>
-      </p:sp>
-      <p:sp>
-        <p:nvSpPr>
-          <p:cNvPr id="23" name="Text 21"/>
-          <p:cNvSpPr/>
-          <p:nvPr/>
-        </p:nvSpPr>
-        <p:spPr>
-          <a:xfrm>
-            <a:off x="2788920" y="4069080"/>
-            <a:ext cx="2926080" cy="384048"/>
-          </a:xfrm>
-          <a:prstGeom prst="rect">
-            <a:avLst/>
-          </a:prstGeom>
-          <a:noFill/>
-          <a:ln/>
-        </p:spPr>
-        <p:txBody>
-          <a:bodyPr wrap="square" lIns="0" tIns="0" rIns="0" bIns="0" rtlCol="0" anchor="ctr"/>
-          <a:lstStyle/>
-          <a:p>
-            <a:pPr indent="0" marL="0">
-              <a:buNone/>
-            </a:pPr>
-            <a:r>
-              <a:rPr lang="en-US" sz="1150" dirty="0">
-                <a:solidFill>
-                  <a:srgbClr val="334155"/>
-                </a:solidFill>
-                <a:latin typeface="Calibri" pitchFamily="34" charset="0"/>
-                <a:ea typeface="Calibri" pitchFamily="34" charset="-122"/>
-                <a:cs typeface="Calibri" pitchFamily="34" charset="-120"/>
-              </a:rPr>
-              <a:t>construction du prompt (contexte + consigne)</a:t>
-            </a:r>
-            <a:endParaRPr lang="en-US" sz="1150" dirty="0"/>
-          </a:p>
-        </p:txBody>
-      </p:sp>
-      <p:sp>
-        <p:nvSpPr>
-          <p:cNvPr id="24" name="Text 22"/>
-          <p:cNvSpPr/>
-          <p:nvPr/>
-        </p:nvSpPr>
-        <p:spPr>
-          <a:xfrm>
-            <a:off x="822960" y="4617720"/>
-            <a:ext cx="1920240" cy="384048"/>
-          </a:xfrm>
-          <a:prstGeom prst="rect">
-            <a:avLst/>
-          </a:prstGeom>
-          <a:noFill/>
-          <a:ln/>
-        </p:spPr>
-        <p:txBody>
-          <a:bodyPr wrap="square" lIns="0" tIns="0" rIns="0" bIns="0" rtlCol="0" anchor="ctr"/>
-          <a:lstStyle/>
-          <a:p>
-            <a:pPr indent="0" marL="0">
-              <a:buNone/>
-            </a:pPr>
-            <a:r>
-              <a:rPr lang="en-US" sz="1200" b="1" dirty="0">
-                <a:solidFill>
-                  <a:srgbClr val="065A82"/>
-                </a:solidFill>
-                <a:latin typeface="Courier New" pitchFamily="34" charset="0"/>
-                <a:ea typeface="Courier New" pitchFamily="34" charset="-122"/>
-                <a:cs typeface="Courier New" pitchFamily="34" charset="-120"/>
-              </a:rPr>
-              <a:t>test_health.py</a:t>
-            </a:r>
-            <a:endParaRPr lang="en-US" sz="1200" dirty="0"/>
-          </a:p>
-        </p:txBody>
-      </p:sp>
-      <p:sp>
-        <p:nvSpPr>
-          <p:cNvPr id="25" name="Text 23"/>
-          <p:cNvSpPr/>
-          <p:nvPr/>
-        </p:nvSpPr>
-        <p:spPr>
-          <a:xfrm>
-            <a:off x="2788920" y="4617720"/>
-            <a:ext cx="2926080" cy="384048"/>
-          </a:xfrm>
-          <a:prstGeom prst="rect">
-            <a:avLst/>
-          </a:prstGeom>
-          <a:noFill/>
-          <a:ln/>
-        </p:spPr>
-        <p:txBody>
-          <a:bodyPr wrap="square" lIns="0" tIns="0" rIns="0" bIns="0" rtlCol="0" anchor="ctr"/>
-          <a:lstStyle/>
-          <a:p>
-            <a:pPr indent="0" marL="0">
-              <a:buNone/>
-            </a:pPr>
-            <a:r>
-              <a:rPr lang="en-US" sz="1150" dirty="0">
-                <a:solidFill>
-                  <a:srgbClr val="334155"/>
-                </a:solidFill>
-                <a:latin typeface="Calibri" pitchFamily="34" charset="0"/>
-                <a:ea typeface="Calibri" pitchFamily="34" charset="-122"/>
-                <a:cs typeface="Calibri" pitchFamily="34" charset="-120"/>
-              </a:rPr>
-              <a:t>disponibilité de /health, validation /ask</a:t>
-            </a:r>
-            <a:endParaRPr lang="en-US" sz="1150" dirty="0"/>
-          </a:p>
-        </p:txBody>
-      </p:sp>
-      <p:sp>
-        <p:nvSpPr>
-          <p:cNvPr id="26" name="Shape 24"/>
+              <a:t>Les tests unitaires vivent directement dans le sous-module backend (pytest.ini, tests/), maintenus par le développeur backend et exécutés via working-directory: backend dans la CI.</a:t>
+            </a:r>
+            <a:endParaRPr lang="en-US" sz="1250" dirty="0"/>
+          </a:p>
+        </p:txBody>
+      </p:sp>
+      <p:sp>
+        <p:nvSpPr>
+          <p:cNvPr id="21" name="Shape 19"/>
           <p:cNvSpPr/>
           <p:nvPr/>
         </p:nvSpPr>
@@ -10631,7 +10985,7 @@
       </p:sp>
       <p:sp>
         <p:nvSpPr>
-          <p:cNvPr id="27" name="Text 25"/>
+          <p:cNvPr id="22" name="Text 20"/>
           <p:cNvSpPr/>
           <p:nvPr/>
         </p:nvSpPr>
@@ -10662,7 +11016,7 @@
                 <a:ea typeface="Calibri" pitchFamily="34" charset="-122"/>
                 <a:cs typeface="Calibri" pitchFamily="34" charset="-120"/>
               </a:rPr>
-              <a:t>Pourquoi une CI rapide ?</a:t>
+              <a:t>Sous-modules git</a:t>
             </a:r>
             <a:endParaRPr lang="en-US" sz="1400" dirty="0"/>
           </a:p>
@@ -10670,7 +11024,7 @@
       </p:sp>
       <p:sp>
         <p:nvSpPr>
-          <p:cNvPr id="28" name="Text 26"/>
+          <p:cNvPr id="23" name="Text 21"/>
           <p:cNvSpPr/>
           <p:nvPr/>
         </p:nvSpPr>
@@ -10704,65 +11058,7 @@
                 <a:ea typeface="Calibri" pitchFamily="34" charset="-122"/>
                 <a:cs typeface="Calibri" pitchFamily="34" charset="-120"/>
               </a:rPr>
-              <a:t>requirements-ci.txt n'installe ni PyTorch, ni ChromaDB, ni Ollama.</a:t>
-            </a:r>
-            <a:endParaRPr lang="en-US" sz="1250" dirty="0"/>
-          </a:p>
-          <a:p>
-            <a:pPr indent="0" marL="0">
-              <a:lnSpc>
-                <a:spcPct val="125000"/>
-              </a:lnSpc>
-              <a:buNone/>
-            </a:pPr>
-            <a:endParaRPr lang="en-US" sz="1250" dirty="0"/>
-          </a:p>
-          <a:p>
-            <a:pPr indent="0" marL="0">
-              <a:lnSpc>
-                <a:spcPct val="125000"/>
-              </a:lnSpc>
-              <a:buNone/>
-            </a:pPr>
-            <a:r>
-              <a:rPr lang="en-US" sz="1250" dirty="0">
-                <a:solidFill>
-                  <a:srgbClr val="334155"/>
-                </a:solidFill>
-                <a:latin typeface="Calibri" pitchFamily="34" charset="0"/>
-                <a:ea typeface="Calibri" pitchFamily="34" charset="-122"/>
-                <a:cs typeface="Calibri" pitchFamily="34" charset="-120"/>
-              </a:rPr>
-              <a:t>Grâce aux imports paresseux dans backend/rag/*.py, les tests n'ont jamais besoin de charger un modèle ML.</a:t>
-            </a:r>
-            <a:endParaRPr lang="en-US" sz="1250" dirty="0"/>
-          </a:p>
-          <a:p>
-            <a:pPr indent="0" marL="0">
-              <a:lnSpc>
-                <a:spcPct val="125000"/>
-              </a:lnSpc>
-              <a:buNone/>
-            </a:pPr>
-            <a:endParaRPr lang="en-US" sz="1250" dirty="0"/>
-          </a:p>
-          <a:p>
-            <a:pPr indent="0" marL="0">
-              <a:lnSpc>
-                <a:spcPct val="125000"/>
-              </a:lnSpc>
-              <a:buNone/>
-            </a:pPr>
-            <a:r>
-              <a:rPr lang="en-US" sz="1250" dirty="0">
-                <a:solidFill>
-                  <a:srgbClr val="334155"/>
-                </a:solidFill>
-                <a:latin typeface="Calibri" pitchFamily="34" charset="0"/>
-                <a:ea typeface="Calibri" pitchFamily="34" charset="-122"/>
-                <a:cs typeface="Calibri" pitchFamily="34" charset="-120"/>
-              </a:rPr>
-              <a:t>Résultat : quelques secondes en CI, au lieu de plusieurs minutes de téléchargement.</a:t>
+              <a:t>backend/ et frontend/ sont des sous-modules git (dépôts séparés). La CI utilise submodules: recursive au checkout pour en récupérer le vrai contenu, sinon ces dossiers apparaissent vides.</a:t>
             </a:r>
             <a:endParaRPr lang="en-US" sz="1250" dirty="0"/>
           </a:p>

</xml_diff>